<commit_message>
access paper about CMV
</commit_message>
<xml_diff>
--- a/Switching Function - Reduced CMV PWM/OnlineCPSCalculation.pptx
+++ b/Switching Function - Reduced CMV PWM/OnlineCPSCalculation.pptx
@@ -216,7 +216,7 @@
           <a:p>
             <a:fld id="{CAC3C920-8099-44FB-877D-FFD02840B4C1}" type="datetimeFigureOut">
               <a:rPr lang="sv-SE" smtClean="0"/>
-              <a:t>2023-07-04</a:t>
+              <a:t>2024-10-16</a:t>
             </a:fld>
             <a:endParaRPr lang="sv-SE"/>
           </a:p>
@@ -1035,7 +1035,7 @@
           <a:p>
             <a:fld id="{1CCF258A-C4AC-452A-B440-6EC022A8E4C9}" type="datetimeFigureOut">
               <a:rPr lang="sv-SE" smtClean="0"/>
-              <a:t>2023-07-04</a:t>
+              <a:t>2024-10-16</a:t>
             </a:fld>
             <a:endParaRPr lang="sv-SE"/>
           </a:p>
@@ -1205,7 +1205,7 @@
           <a:p>
             <a:fld id="{1CCF258A-C4AC-452A-B440-6EC022A8E4C9}" type="datetimeFigureOut">
               <a:rPr lang="sv-SE" smtClean="0"/>
-              <a:t>2023-07-04</a:t>
+              <a:t>2024-10-16</a:t>
             </a:fld>
             <a:endParaRPr lang="sv-SE"/>
           </a:p>
@@ -1385,7 +1385,7 @@
           <a:p>
             <a:fld id="{1CCF258A-C4AC-452A-B440-6EC022A8E4C9}" type="datetimeFigureOut">
               <a:rPr lang="sv-SE" smtClean="0"/>
-              <a:t>2023-07-04</a:t>
+              <a:t>2024-10-16</a:t>
             </a:fld>
             <a:endParaRPr lang="sv-SE"/>
           </a:p>
@@ -1555,7 +1555,7 @@
           <a:p>
             <a:fld id="{1CCF258A-C4AC-452A-B440-6EC022A8E4C9}" type="datetimeFigureOut">
               <a:rPr lang="sv-SE" smtClean="0"/>
-              <a:t>2023-07-04</a:t>
+              <a:t>2024-10-16</a:t>
             </a:fld>
             <a:endParaRPr lang="sv-SE"/>
           </a:p>
@@ -1801,7 +1801,7 @@
           <a:p>
             <a:fld id="{1CCF258A-C4AC-452A-B440-6EC022A8E4C9}" type="datetimeFigureOut">
               <a:rPr lang="sv-SE" smtClean="0"/>
-              <a:t>2023-07-04</a:t>
+              <a:t>2024-10-16</a:t>
             </a:fld>
             <a:endParaRPr lang="sv-SE"/>
           </a:p>
@@ -2033,7 +2033,7 @@
           <a:p>
             <a:fld id="{1CCF258A-C4AC-452A-B440-6EC022A8E4C9}" type="datetimeFigureOut">
               <a:rPr lang="sv-SE" smtClean="0"/>
-              <a:t>2023-07-04</a:t>
+              <a:t>2024-10-16</a:t>
             </a:fld>
             <a:endParaRPr lang="sv-SE"/>
           </a:p>
@@ -2400,7 +2400,7 @@
           <a:p>
             <a:fld id="{1CCF258A-C4AC-452A-B440-6EC022A8E4C9}" type="datetimeFigureOut">
               <a:rPr lang="sv-SE" smtClean="0"/>
-              <a:t>2023-07-04</a:t>
+              <a:t>2024-10-16</a:t>
             </a:fld>
             <a:endParaRPr lang="sv-SE"/>
           </a:p>
@@ -2518,7 +2518,7 @@
           <a:p>
             <a:fld id="{1CCF258A-C4AC-452A-B440-6EC022A8E4C9}" type="datetimeFigureOut">
               <a:rPr lang="sv-SE" smtClean="0"/>
-              <a:t>2023-07-04</a:t>
+              <a:t>2024-10-16</a:t>
             </a:fld>
             <a:endParaRPr lang="sv-SE"/>
           </a:p>
@@ -2613,7 +2613,7 @@
           <a:p>
             <a:fld id="{1CCF258A-C4AC-452A-B440-6EC022A8E4C9}" type="datetimeFigureOut">
               <a:rPr lang="sv-SE" smtClean="0"/>
-              <a:t>2023-07-04</a:t>
+              <a:t>2024-10-16</a:t>
             </a:fld>
             <a:endParaRPr lang="sv-SE"/>
           </a:p>
@@ -2890,7 +2890,7 @@
           <a:p>
             <a:fld id="{1CCF258A-C4AC-452A-B440-6EC022A8E4C9}" type="datetimeFigureOut">
               <a:rPr lang="sv-SE" smtClean="0"/>
-              <a:t>2023-07-04</a:t>
+              <a:t>2024-10-16</a:t>
             </a:fld>
             <a:endParaRPr lang="sv-SE"/>
           </a:p>
@@ -3143,7 +3143,7 @@
           <a:p>
             <a:fld id="{1CCF258A-C4AC-452A-B440-6EC022A8E4C9}" type="datetimeFigureOut">
               <a:rPr lang="sv-SE" smtClean="0"/>
-              <a:t>2023-07-04</a:t>
+              <a:t>2024-10-16</a:t>
             </a:fld>
             <a:endParaRPr lang="sv-SE"/>
           </a:p>
@@ -3356,7 +3356,7 @@
           <a:p>
             <a:fld id="{1CCF258A-C4AC-452A-B440-6EC022A8E4C9}" type="datetimeFigureOut">
               <a:rPr lang="sv-SE" smtClean="0"/>
-              <a:t>2023-07-04</a:t>
+              <a:t>2024-10-16</a:t>
             </a:fld>
             <a:endParaRPr lang="sv-SE"/>
           </a:p>

</xml_diff>